<commit_message>
Reporte 9 de marzo
</commit_message>
<xml_diff>
--- a/Reporte 060326.pptx
+++ b/Reporte 060326.pptx
@@ -6047,7 +6047,7 @@
                 <a:latin typeface="Montserrat Black"/>
                 <a:sym typeface="Arial"/>
               </a:rPr>
-              <a:t>Elaborado: 5</a:t>
+              <a:t>Elaborado: 6</a:t>
             </a:r>
             <a:r>
               <a:rPr lang="es-MX" sz="1600" dirty="0">
@@ -6173,10 +6173,10 @@
       </p:sp>
       <p:pic>
         <p:nvPicPr>
-          <p:cNvPr id="7" name="Imagen 6">
+          <p:cNvPr id="3" name="Imagen 2">
             <a:extLst>
               <a:ext uri="{FF2B5EF4-FFF2-40B4-BE49-F238E27FC236}">
-                <a16:creationId xmlns:a16="http://schemas.microsoft.com/office/drawing/2014/main" id="{FC440B4F-DDA8-55DF-1699-B4C0954EE619}"/>
+                <a16:creationId xmlns:a16="http://schemas.microsoft.com/office/drawing/2014/main" id="{500F2A4F-7BAF-9FC3-8A5E-9929A72D3CFA}"/>
               </a:ext>
             </a:extLst>
           </p:cNvPr>
@@ -6193,8 +6193,8 @@
         </p:blipFill>
         <p:spPr>
           <a:xfrm>
-            <a:off x="205535" y="369332"/>
-            <a:ext cx="8659906" cy="4687471"/>
+            <a:off x="0" y="727625"/>
+            <a:ext cx="9144000" cy="3688250"/>
           </a:xfrm>
           <a:prstGeom prst="rect">
             <a:avLst/>
@@ -6271,10 +6271,10 @@
       </p:sp>
       <p:pic>
         <p:nvPicPr>
-          <p:cNvPr id="5" name="Imagen 4">
+          <p:cNvPr id="4" name="Imagen 3">
             <a:extLst>
               <a:ext uri="{FF2B5EF4-FFF2-40B4-BE49-F238E27FC236}">
-                <a16:creationId xmlns:a16="http://schemas.microsoft.com/office/drawing/2014/main" id="{F6A17533-43E5-DD2D-91E3-6638555D8F82}"/>
+                <a16:creationId xmlns:a16="http://schemas.microsoft.com/office/drawing/2014/main" id="{81C797CC-67B3-C49F-567D-94745CD28C49}"/>
               </a:ext>
             </a:extLst>
           </p:cNvPr>
@@ -6291,8 +6291,8 @@
         </p:blipFill>
         <p:spPr>
           <a:xfrm>
-            <a:off x="0" y="653111"/>
-            <a:ext cx="9144000" cy="3837277"/>
+            <a:off x="0" y="830520"/>
+            <a:ext cx="9144000" cy="3482459"/>
           </a:xfrm>
           <a:prstGeom prst="rect">
             <a:avLst/>
@@ -6369,10 +6369,10 @@
       </p:sp>
       <p:pic>
         <p:nvPicPr>
-          <p:cNvPr id="4" name="Imagen 3">
+          <p:cNvPr id="3" name="Imagen 2">
             <a:extLst>
               <a:ext uri="{FF2B5EF4-FFF2-40B4-BE49-F238E27FC236}">
-                <a16:creationId xmlns:a16="http://schemas.microsoft.com/office/drawing/2014/main" id="{4F72199A-99CA-B527-072B-FD887DA6B07F}"/>
+                <a16:creationId xmlns:a16="http://schemas.microsoft.com/office/drawing/2014/main" id="{260FCF9A-C243-106E-9DD3-8780C6D6E1CB}"/>
               </a:ext>
             </a:extLst>
           </p:cNvPr>
@@ -6389,8 +6389,8 @@
         </p:blipFill>
         <p:spPr>
           <a:xfrm>
-            <a:off x="0" y="1110812"/>
-            <a:ext cx="9144000" cy="2921876"/>
+            <a:off x="0" y="1215584"/>
+            <a:ext cx="9144000" cy="2712332"/>
           </a:xfrm>
           <a:prstGeom prst="rect">
             <a:avLst/>
@@ -6467,10 +6467,10 @@
       </p:sp>
       <p:pic>
         <p:nvPicPr>
-          <p:cNvPr id="4" name="Imagen 3">
+          <p:cNvPr id="3" name="Imagen 2">
             <a:extLst>
               <a:ext uri="{FF2B5EF4-FFF2-40B4-BE49-F238E27FC236}">
-                <a16:creationId xmlns:a16="http://schemas.microsoft.com/office/drawing/2014/main" id="{FE9F976D-88B8-AEEB-C887-FF67555AAC6D}"/>
+                <a16:creationId xmlns:a16="http://schemas.microsoft.com/office/drawing/2014/main" id="{8040DE82-FF8E-8740-8EA6-89B870B74BA9}"/>
               </a:ext>
             </a:extLst>
           </p:cNvPr>
@@ -6487,8 +6487,8 @@
         </p:blipFill>
         <p:spPr>
           <a:xfrm>
-            <a:off x="0" y="1230957"/>
-            <a:ext cx="9144000" cy="2681586"/>
+            <a:off x="0" y="1368592"/>
+            <a:ext cx="9144000" cy="2406316"/>
           </a:xfrm>
           <a:prstGeom prst="rect">
             <a:avLst/>
@@ -6571,10 +6571,10 @@
       </p:sp>
       <p:pic>
         <p:nvPicPr>
-          <p:cNvPr id="3" name="Imagen 2">
+          <p:cNvPr id="4" name="Imagen 3">
             <a:extLst>
               <a:ext uri="{FF2B5EF4-FFF2-40B4-BE49-F238E27FC236}">
-                <a16:creationId xmlns:a16="http://schemas.microsoft.com/office/drawing/2014/main" id="{F6CBF3F2-2D38-D8FB-1992-BFF281610799}"/>
+                <a16:creationId xmlns:a16="http://schemas.microsoft.com/office/drawing/2014/main" id="{00BD0867-6E1A-BF40-FCDB-A6B530D7AB7C}"/>
               </a:ext>
             </a:extLst>
           </p:cNvPr>
@@ -6591,8 +6591,8 @@
         </p:blipFill>
         <p:spPr>
           <a:xfrm>
-            <a:off x="361362" y="704589"/>
-            <a:ext cx="8421275" cy="3734321"/>
+            <a:off x="1685522" y="337825"/>
+            <a:ext cx="5772956" cy="4467849"/>
           </a:xfrm>
           <a:prstGeom prst="rect">
             <a:avLst/>
@@ -7391,10 +7391,10 @@
       </p:sp>
       <p:pic>
         <p:nvPicPr>
-          <p:cNvPr id="7" name="Imagen 6">
+          <p:cNvPr id="4" name="Imagen 3">
             <a:extLst>
               <a:ext uri="{FF2B5EF4-FFF2-40B4-BE49-F238E27FC236}">
-                <a16:creationId xmlns:a16="http://schemas.microsoft.com/office/drawing/2014/main" id="{83241F5A-B42C-9519-80C6-9F6816F2CD14}"/>
+                <a16:creationId xmlns:a16="http://schemas.microsoft.com/office/drawing/2014/main" id="{9777520B-FC57-D5D1-FC00-5D257116571E}"/>
               </a:ext>
             </a:extLst>
           </p:cNvPr>
@@ -7411,8 +7411,8 @@
         </p:blipFill>
         <p:spPr>
           <a:xfrm>
-            <a:off x="132942" y="369332"/>
-            <a:ext cx="8805091" cy="4774168"/>
+            <a:off x="0" y="405772"/>
+            <a:ext cx="9144000" cy="4474832"/>
           </a:xfrm>
           <a:prstGeom prst="rect">
             <a:avLst/>
@@ -7489,10 +7489,10 @@
       </p:sp>
       <p:pic>
         <p:nvPicPr>
-          <p:cNvPr id="7" name="Imagen 6">
+          <p:cNvPr id="3" name="Imagen 2">
             <a:extLst>
               <a:ext uri="{FF2B5EF4-FFF2-40B4-BE49-F238E27FC236}">
-                <a16:creationId xmlns:a16="http://schemas.microsoft.com/office/drawing/2014/main" id="{CB878565-BE85-9199-6DC7-3FEAD5519C71}"/>
+                <a16:creationId xmlns:a16="http://schemas.microsoft.com/office/drawing/2014/main" id="{0A50C18B-1BB5-9DAE-2162-4526F3DBA95B}"/>
               </a:ext>
             </a:extLst>
           </p:cNvPr>
@@ -7509,8 +7509,8 @@
         </p:blipFill>
         <p:spPr>
           <a:xfrm>
-            <a:off x="0" y="762933"/>
-            <a:ext cx="9144000" cy="3617634"/>
+            <a:off x="0" y="1006706"/>
+            <a:ext cx="9144000" cy="3272963"/>
           </a:xfrm>
           <a:prstGeom prst="rect">
             <a:avLst/>

</xml_diff>